<commit_message>
v13: trim script to fit 5 minutes
Co-Authored-By: Claude Opus 5.5 <noreply@anthropic.com>
Claude-Session: https://claude.ai/code/session_01Qadxmh2cuTPoezLniB2znE
</commit_message>
<xml_diff>
--- a/학생자율연구II_연구계획발표/v13_도식구성/학생자율연구II_연구계획발표_v13.pptx
+++ b/학생자율연구II_연구계획발표/v13_도식구성/학생자율연구II_연구계획발표_v13.pptx
@@ -1782,7 +1782,7 @@
           </a:p>
           <a:p>
             <a:r>
-              <a:t>실험 조건은 직선 주행, 선회, 정지와 출발, 영상 품질이 떨어지는 구간으로 나누고, 영상을 흐리게 하거나 프레임을 빼는 실험도 따로 기록합니다. 평가는 위치 RMSE, 최종 위치 오차, 영상이 끊겼을 때 오차가 얼마나 늘어나는지를 중심으로, 속도 RMSE와 처리시간도 봅니다.</a:t>
+              <a:t>실험 조건은 직선 주행, 선회, 정지와 출발, 영상 품질이 떨어지는 구간으로 나누고, 영상을 흐리게 하거나 프레임을 빼는 실험도 따로 기록합니다. 평가는 위치 오차와 영상 중단 시 오차 증가량이 중심입니다.</a:t>
             </a:r>
           </a:p>
         </p:txBody>
@@ -2121,7 +2121,7 @@
           </a:p>
           <a:p>
             <a:r>
-              <a:t>(왼쪽) 가장 기본은 IMU만 쓰는 관성항법인데, 가속도와 각속도를 적분하기 때문에 잡음과 바이어스가 쌓여 시간이 갈수록 오차가 커집니다. (오른쪽) 그래서 카메라 영상의 움직임으로 이 오차를 보정하는 비전 보조 항법을 씁니다. NASA의 화성 헬리콥터 인저뉴어티도 아래를 보는 카메라와 IMU로 비행했습니다.</a:t>
+              <a:t>(왼쪽) 가장 기본은 IMU만 쓰는 관성항법인데, 가속도와 각속도를 적분하기 때문에 잡음과 바이어스가 쌓여 시간이 갈수록 오차가 커집니다. (오른쪽) 그래서 카메라 영상의 움직임으로 이 오차를 보정하는 비전 보조 항법을 씁니다.</a:t>
             </a:r>
           </a:p>
         </p:txBody>
@@ -2458,7 +2458,7 @@
           </a:p>
           <a:p>
             <a:r>
-              <a:t>상태추정 필터는 두 단계를 반복합니다. (위 그림) IMU 입력으로 다음 상태를 예측하고, 카메라 관측으로 그 예측을 고칩니다. 예측하면 불확실성이 커지고, 보정하면 줄어듭니다.</a:t>
+              <a:t>상태추정 필터는 두 단계를 반복합니다. (위 그림) IMU 입력으로 다음 상태를 예측하고, 카메라 관측으로 그 예측을 고칩니다.</a:t>
             </a:r>
           </a:p>
           <a:p>
@@ -2572,12 +2572,12 @@
           </a:p>
           <a:p>
             <a:r>
-              <a:t>(위 식) 아래를 보는 카메라에서 영상 속 이동은 대략 실제 이동 속도를 높이로 나눈 성분과 회전 성분의 합입니다. 즉, 기체가 제자리에서 기울기만 해도 영상은 움직이고, 같은 속도라도 높이에 따라 영상 이동이 달라집니다.</a:t>
-            </a:r>
-          </a:p>
-          <a:p>
-            <a:r>
-              <a:t>(아래 흐름) 그래서 연속 영상에서 KLT로 특징점을 추적한 뒤, 자이로로 회전 성분을 빼고, 카메라 높이와 평면 가정으로 실제 크기로 바꿔서 속도 관측으로 필터에 넣습니다. 이때 카메라 보정값, 장착 위치와 방향, 좌표계도 함께 맞춰야 합니다.</a:t>
+              <a:t>(위 식) 아래를 보는 카메라에서 영상 속 이동은 대략 실제 이동 속도를 높이로 나눈 성분과 회전 성분의 합입니다. </a:t>
+            </a:r>
+          </a:p>
+          <a:p>
+            <a:r>
+              <a:t>(아래 흐름) 그래서 연속 영상에서 KLT로 특징점을 추적한 뒤, 자이로로 회전 성분을 빼고, 카메라 높이와 평면 가정으로 실제 크기로 바꿔서 속도 관측으로 필터에 넣습니다.</a:t>
             </a:r>
           </a:p>
         </p:txBody>
@@ -2691,7 +2691,7 @@
           </a:p>
           <a:p>
             <a:r>
-              <a:t>(오른쪽) 신뢰도가 높으면 평소처럼 보정하고, 낮으면 관측 잡음을 크게 잡아 보정 비중을 줄이며, 유효한 관측이 아예 없으면 보정을 건너뛰고 IMU 예측을 유지합니다. 이 기준은 조정용 구간에서 정하고, 결과는 별도의 평가 구간에서 확인합니다. 이렇게 해서 영상이 나빠지는 구간에서도 추정이 무너지지 않게 하는 것이 목표입니다.</a:t>
+              <a:t>(오른쪽) 신뢰도가 높으면 평소처럼 보정하고, 낮으면 관측 잡음을 크게 잡아 보정 비중을 줄이며, 유효한 관측이 아예 없으면 보정을 건너뛰고 IMU 예측을 유지합니다. 이 기준은 조정용 구간에서 정하고, 결과는 별도의 평가 구간에서 확인합니다.</a:t>
             </a:r>
           </a:p>
         </p:txBody>
@@ -2805,7 +2805,7 @@
           </a:p>
           <a:p>
             <a:r>
-              <a:t>GPS는 입력에서 완전히 빼고, 기준 궤적은 성능 평가에만 씁니다. 구현은 매트랩으로 하며, 센서 주기와 시간 동기화, 좌표계는 연구실의 시간 정합 절차를 참고해 맞춥니다.</a:t>
+              <a:t>GPS는 입력에서 완전히 빼고, 기준 궤적은 성능 평가에만 씁니다.</a:t>
             </a:r>
           </a:p>
         </p:txBody>

</xml_diff>